<commit_message>
Update submission workflow for banking dataset
</commit_message>
<xml_diff>
--- a/submission/ChurnZero_26_Round2_Presentation.pptx
+++ b/submission/ChurnZero_26_Round2_Presentation.pptx
@@ -3330,7 +3330,7 @@
               </a:defRPr>
             </a:pPr>
             <a:r>
-              <a:t>0.726</a:t>
+              <a:t>0.945</a:t>
             </a:r>
           </a:p>
           <a:p>
@@ -3396,7 +3396,7 @@
               </a:defRPr>
             </a:pPr>
             <a:r>
-              <a:t>0.284</a:t>
+              <a:t>0.648</a:t>
             </a:r>
           </a:p>
           <a:p>
@@ -3462,7 +3462,7 @@
               </a:defRPr>
             </a:pPr>
             <a:r>
-              <a:t>0.347</a:t>
+              <a:t>0.645</a:t>
             </a:r>
           </a:p>
           <a:p>
@@ -3887,7 +3887,7 @@
               </a:defRPr>
             </a:pPr>
             <a:r>
-              <a:t>python scripts/train.py --train data/raw/train.csv --test data/raw/test.csv --target Exited</a:t>
+              <a:t>python scripts/train.py --train data/raw/banking.csv --target y</a:t>
             </a:r>
           </a:p>
           <a:p>
@@ -3902,7 +3902,7 @@
               </a:defRPr>
             </a:pPr>
             <a:r>
-              <a:t>python scripts/predict.py --model models/churn_model.joblib --test data/raw/test.csv --out outputs/predictions.csv</a:t>
+              <a:t>python scripts/predict.py --model models/churn_model.joblib --test data/raw/banking.csv --out outputs/predictions.csv</a:t>
             </a:r>
           </a:p>
           <a:p>
@@ -4759,7 +4759,7 @@
               </a:defRPr>
             </a:pPr>
             <a:r>
-              <a:t>8000</a:t>
+              <a:t>41188</a:t>
             </a:r>
           </a:p>
           <a:p>
@@ -4825,7 +4825,7 @@
               </a:defRPr>
             </a:pPr>
             <a:r>
-              <a:t>14</a:t>
+              <a:t>21</a:t>
             </a:r>
           </a:p>
           <a:p>
@@ -4891,7 +4891,7 @@
               </a:defRPr>
             </a:pPr>
             <a:r>
-              <a:t>12.1%</a:t>
+              <a:t>11.3%</a:t>
             </a:r>
           </a:p>
           <a:p>
@@ -4957,7 +4957,7 @@
               </a:defRPr>
             </a:pPr>
             <a:r>
-              <a:t>10</a:t>
+              <a:t>20</a:t>
             </a:r>
           </a:p>
           <a:p>
@@ -5650,7 +5650,7 @@
               </a:defRPr>
             </a:pPr>
             <a:r>
-              <a:t>0.726</a:t>
+              <a:t>0.945</a:t>
             </a:r>
           </a:p>
           <a:p>
@@ -5716,7 +5716,7 @@
               </a:defRPr>
             </a:pPr>
             <a:r>
-              <a:t>0.284</a:t>
+              <a:t>0.648</a:t>
             </a:r>
           </a:p>
           <a:p>
@@ -5782,7 +5782,7 @@
               </a:defRPr>
             </a:pPr>
             <a:r>
-              <a:t>0.305</a:t>
+              <a:t>0.533</a:t>
             </a:r>
           </a:p>
           <a:p>
@@ -5848,7 +5848,7 @@
               </a:defRPr>
             </a:pPr>
             <a:r>
-              <a:t>0.402</a:t>
+              <a:t>0.816</a:t>
             </a:r>
           </a:p>
           <a:p>
@@ -5914,7 +5914,7 @@
               </a:defRPr>
             </a:pPr>
             <a:r>
-              <a:t>0.347</a:t>
+              <a:t>0.645</a:t>
             </a:r>
           </a:p>
           <a:p>
@@ -6390,7 +6390,7 @@
               </a:defRPr>
             </a:pPr>
             <a:r>
-              <a:t>Top signal: Age</a:t>
+              <a:t>Top signal: duration</a:t>
             </a:r>
           </a:p>
           <a:p>
@@ -6405,7 +6405,7 @@
               </a:defRPr>
             </a:pPr>
             <a:r>
-              <a:t>Top signal: CreditScore</a:t>
+              <a:t>Top signal: emp_var_rate</a:t>
             </a:r>
           </a:p>
           <a:p>
@@ -6420,7 +6420,7 @@
               </a:defRPr>
             </a:pPr>
             <a:r>
-              <a:t>Top signal: Geography</a:t>
+              <a:t>Top signal: euribor3m</a:t>
             </a:r>
           </a:p>
           <a:p>
@@ -6435,7 +6435,7 @@
               </a:defRPr>
             </a:pPr>
             <a:r>
-              <a:t>Top signal: IsActiveMember</a:t>
+              <a:t>Top signal: nr_employed</a:t>
             </a:r>
           </a:p>
           <a:p>
@@ -6450,7 +6450,7 @@
               </a:defRPr>
             </a:pPr>
             <a:r>
-              <a:t>Top signal: Balance</a:t>
+              <a:t>Top signal: pdays</a:t>
             </a:r>
           </a:p>
           <a:p>
@@ -6465,7 +6465,7 @@
               </a:defRPr>
             </a:pPr>
             <a:r>
-              <a:t>Top signal: NumOfProducts</a:t>
+              <a:t>Top signal: day_of_week</a:t>
             </a:r>
           </a:p>
         </p:txBody>

</xml_diff>

<commit_message>
feat: retrain churn prediction model on official ChurnZero round 2 dataset, update predictions and metrics
</commit_message>
<xml_diff>
--- a/submission/ChurnZero_26_Round2_Presentation.pptx
+++ b/submission/ChurnZero_26_Round2_Presentation.pptx
@@ -3330,7 +3330,7 @@
               </a:defRPr>
             </a:pPr>
             <a:r>
-              <a:t>0.945</a:t>
+              <a:t>1.000</a:t>
             </a:r>
           </a:p>
           <a:p>
@@ -3396,7 +3396,7 @@
               </a:defRPr>
             </a:pPr>
             <a:r>
-              <a:t>0.648</a:t>
+              <a:t>1.000</a:t>
             </a:r>
           </a:p>
           <a:p>
@@ -3462,7 +3462,7 @@
               </a:defRPr>
             </a:pPr>
             <a:r>
-              <a:t>0.645</a:t>
+              <a:t>0.992</a:t>
             </a:r>
           </a:p>
           <a:p>
@@ -4759,7 +4759,7 @@
               </a:defRPr>
             </a:pPr>
             <a:r>
-              <a:t>41188</a:t>
+              <a:t>8101</a:t>
             </a:r>
           </a:p>
           <a:p>
@@ -4825,7 +4825,7 @@
               </a:defRPr>
             </a:pPr>
             <a:r>
-              <a:t>21</a:t>
+              <a:t>98</a:t>
             </a:r>
           </a:p>
           <a:p>
@@ -4891,7 +4891,7 @@
               </a:defRPr>
             </a:pPr>
             <a:r>
-              <a:t>11.3%</a:t>
+              <a:t>16.1%</a:t>
             </a:r>
           </a:p>
           <a:p>
@@ -4957,7 +4957,7 @@
               </a:defRPr>
             </a:pPr>
             <a:r>
-              <a:t>20</a:t>
+              <a:t>96</a:t>
             </a:r>
           </a:p>
           <a:p>
@@ -5650,7 +5650,7 @@
               </a:defRPr>
             </a:pPr>
             <a:r>
-              <a:t>0.945</a:t>
+              <a:t>1.000</a:t>
             </a:r>
           </a:p>
           <a:p>
@@ -5716,7 +5716,7 @@
               </a:defRPr>
             </a:pPr>
             <a:r>
-              <a:t>0.648</a:t>
+              <a:t>1.000</a:t>
             </a:r>
           </a:p>
           <a:p>
@@ -5782,7 +5782,7 @@
               </a:defRPr>
             </a:pPr>
             <a:r>
-              <a:t>0.533</a:t>
+              <a:t>0.996</a:t>
             </a:r>
           </a:p>
           <a:p>
@@ -5848,7 +5848,7 @@
               </a:defRPr>
             </a:pPr>
             <a:r>
-              <a:t>0.816</a:t>
+              <a:t>0.989</a:t>
             </a:r>
           </a:p>
           <a:p>
@@ -5914,7 +5914,7 @@
               </a:defRPr>
             </a:pPr>
             <a:r>
-              <a:t>0.645</a:t>
+              <a:t>0.992</a:t>
             </a:r>
           </a:p>
           <a:p>
@@ -6390,7 +6390,7 @@
               </a:defRPr>
             </a:pPr>
             <a:r>
-              <a:t>Top signal: duration</a:t>
+              <a:t>Top signal: balance_decline_percentage</a:t>
             </a:r>
           </a:p>
           <a:p>
@@ -6405,7 +6405,7 @@
               </a:defRPr>
             </a:pPr>
             <a:r>
-              <a:t>Top signal: emp_var_rate</a:t>
+              <a:t>Top signal: unresolved_complaint_count</a:t>
             </a:r>
           </a:p>
           <a:p>
@@ -6420,7 +6420,7 @@
               </a:defRPr>
             </a:pPr>
             <a:r>
-              <a:t>Top signal: euribor3m</a:t>
+              <a:t>Top signal: campaign_response_count</a:t>
             </a:r>
           </a:p>
           <a:p>
@@ -6435,7 +6435,7 @@
               </a:defRPr>
             </a:pPr>
             <a:r>
-              <a:t>Top signal: nr_employed</a:t>
+              <a:t>Top signal: relationship_manager_interaction_count</a:t>
             </a:r>
           </a:p>
           <a:p>
@@ -6450,7 +6450,7 @@
               </a:defRPr>
             </a:pPr>
             <a:r>
-              <a:t>Top signal: pdays</a:t>
+              <a:t>Top signal: total_trans_count</a:t>
             </a:r>
           </a:p>
           <a:p>
@@ -6465,7 +6465,7 @@
               </a:defRPr>
             </a:pPr>
             <a:r>
-              <a:t>Top signal: day_of_week</a:t>
+              <a:t>Top signal: customer_feedback_sentiment</a:t>
             </a:r>
           </a:p>
         </p:txBody>

</xml_diff>